<commit_message>
[Prompt 7] Reformat PPTX text for readability — team name, colors, bold
- Team Name changed from "KrishiRakshak" to "Gwonder" on Slide 1
- All content text: green #1A6B2E -> dark charcoal #333333
- Font size: 11pt -> 12pt for better readability
- Bold keyword prefixes on feature/tech/performance slides
  (e.g., "**Voice Q&A** — description" split into bold + regular)
- Template backgrounds and heading styles untouched
- Diagram images on slides 5, 6, 7 re-embedded from fresh source

Co-Authored-By: Claude Opus 4.6 <noreply@anthropic.com>
</commit_message>
<xml_diff>
--- a/docs/KrishiRakshak_Submission_Final.pptx
+++ b/docs/KrishiRakshak_Submission_Final.pptx
@@ -6871,13 +6871,13 @@
               <a:buNone/>
             </a:pPr>
             <a:r>
-              <a:rPr lang="en-GB" sz="1100" b="0">
-                <a:solidFill>
-                  <a:srgbClr val="1a6b2e"/>
+              <a:rPr lang="en-GB" sz="1200" b="0">
+                <a:solidFill>
+                  <a:srgbClr val="333333"/>
                 </a:solidFill>
                 <a:latin typeface="Manrope"/>
               </a:rPr>
-              <a:t>KrishiRakshak (कृषि रक्षक)</a:t>
+              <a:t>Gwonder</a:t>
             </a:r>
           </a:p>
         </p:txBody>
@@ -6955,9 +6955,9 @@
               <a:buNone/>
             </a:pPr>
             <a:r>
-              <a:rPr lang="en-GB" sz="1100" b="0">
-                <a:solidFill>
-                  <a:srgbClr val="1a6b2e"/>
+              <a:rPr lang="en-GB" sz="1200" b="0">
+                <a:solidFill>
+                  <a:srgbClr val="333333"/>
                 </a:solidFill>
                 <a:latin typeface="Manrope"/>
               </a:rPr>
@@ -7039,9 +7039,9 @@
               <a:buNone/>
             </a:pPr>
             <a:r>
-              <a:rPr lang="en-GB" sz="1100" b="0">
-                <a:solidFill>
-                  <a:srgbClr val="1a6b2e"/>
+              <a:rPr lang="en-GB" sz="1200" b="0">
+                <a:solidFill>
+                  <a:srgbClr val="333333"/>
                 </a:solidFill>
                 <a:latin typeface="Manrope"/>
               </a:rPr>
@@ -7192,9 +7192,9 @@
               <a:buNone/>
             </a:pPr>
             <a:r>
-              <a:rPr lang="en-GB" sz="1100" b="0">
-                <a:solidFill>
-                  <a:srgbClr val="1a6b2e"/>
+              <a:rPr lang="en-GB" sz="1200" b="0">
+                <a:solidFill>
+                  <a:srgbClr val="333333"/>
                 </a:solidFill>
                 <a:latin typeface="Manrope"/>
               </a:rPr>
@@ -7215,9 +7215,9 @@
               <a:buNone/>
             </a:pPr>
             <a:r>
-              <a:rPr lang="en-GB" sz="1100" b="0">
-                <a:solidFill>
-                  <a:srgbClr val="1a6b2e"/>
+              <a:rPr lang="en-GB" sz="1200" b="0">
+                <a:solidFill>
+                  <a:srgbClr val="333333"/>
                 </a:solidFill>
                 <a:latin typeface="Manrope"/>
               </a:rPr>
@@ -7368,9 +7368,9 @@
               <a:buNone/>
             </a:pPr>
             <a:r>
-              <a:rPr lang="en-GB" sz="1100" b="0">
-                <a:solidFill>
-                  <a:srgbClr val="1a6b2e"/>
+              <a:rPr lang="en-GB" sz="1200" b="0">
+                <a:solidFill>
+                  <a:srgbClr val="333333"/>
                 </a:solidFill>
                 <a:latin typeface="Manrope"/>
               </a:rPr>
@@ -7391,13 +7391,22 @@
               <a:buNone/>
             </a:pPr>
             <a:r>
-              <a:rPr lang="en-GB" sz="1100" b="0">
-                <a:solidFill>
-                  <a:srgbClr val="1a6b2e"/>
+              <a:rPr lang="en-GB" sz="1200" b="1">
+                <a:solidFill>
+                  <a:srgbClr val="333333"/>
                 </a:solidFill>
                 <a:latin typeface="Manrope"/>
               </a:rPr>
-              <a:t>Bedrock RAG Voice Q&amp;A: 2.0-3.5 sec  |  Rekognition Hazard Detection: 1.2-2.0 sec  |  Polly Hindi TTS: 0.8-1.5 sec</a:t>
+              <a:t>Bedrock RAG Voice Q&amp;A:</a:t>
+            </a:r>
+            <a:r>
+              <a:rPr lang="en-GB" sz="1200" b="0">
+                <a:solidFill>
+                  <a:srgbClr val="333333"/>
+                </a:solidFill>
+                <a:latin typeface="Manrope"/>
+              </a:rPr>
+              <a:t> 2.0-3.5 sec  |  Rekognition Hazard Detection: 1.2-2.0 sec  |  Polly Hindi TTS: 0.8-1.5 sec</a:t>
             </a:r>
           </a:p>
           <a:p>
@@ -7414,13 +7423,22 @@
               <a:buNone/>
             </a:pPr>
             <a:r>
-              <a:rPr lang="en-GB" sz="1100" b="0">
-                <a:solidFill>
-                  <a:srgbClr val="1a6b2e"/>
+              <a:rPr lang="en-GB" sz="1200" b="1">
+                <a:solidFill>
+                  <a:srgbClr val="333333"/>
                 </a:solidFill>
                 <a:latin typeface="Manrope"/>
               </a:rPr>
-              <a:t>CloudFront PWA page load: ~0.4 sec (cached)  |  DynamoDB write: under 30ms</a:t>
+              <a:t>CloudFront PWA page load:</a:t>
+            </a:r>
+            <a:r>
+              <a:rPr lang="en-GB" sz="1200" b="0">
+                <a:solidFill>
+                  <a:srgbClr val="333333"/>
+                </a:solidFill>
+                <a:latin typeface="Manrope"/>
+              </a:rPr>
+              <a:t> ~0.4 sec (cached)  |  DynamoDB write: under 30ms</a:t>
             </a:r>
           </a:p>
           <a:p>
@@ -7437,13 +7455,22 @@
               <a:buNone/>
             </a:pPr>
             <a:r>
-              <a:rPr lang="en-GB" sz="1100" b="0">
-                <a:solidFill>
-                  <a:srgbClr val="1a6b2e"/>
+              <a:rPr lang="en-GB" sz="1200" b="1">
+                <a:solidFill>
+                  <a:srgbClr val="333333"/>
                 </a:solidFill>
                 <a:latin typeface="Manrope"/>
               </a:rPr>
-              <a:t>Reliability: 99.9%+ uptime, fully serverless, no single point of failure.</a:t>
+              <a:t>Reliability:</a:t>
+            </a:r>
+            <a:r>
+              <a:rPr lang="en-GB" sz="1200" b="0">
+                <a:solidFill>
+                  <a:srgbClr val="333333"/>
+                </a:solidFill>
+                <a:latin typeface="Manrope"/>
+              </a:rPr>
+              <a:t> 99.9%+ uptime, fully serverless, no single point of failure.</a:t>
             </a:r>
           </a:p>
           <a:p>
@@ -7460,13 +7487,22 @@
               <a:buNone/>
             </a:pPr>
             <a:r>
-              <a:rPr lang="en-GB" sz="1100" b="0">
-                <a:solidFill>
-                  <a:srgbClr val="1a6b2e"/>
+              <a:rPr lang="en-GB" sz="1200" b="1">
+                <a:solidFill>
+                  <a:srgbClr val="333333"/>
                 </a:solidFill>
                 <a:latin typeface="Manrope"/>
               </a:rPr>
-              <a:t>Scalability: Lambda auto-scales 0 to 1,000+ concurrent executions.</a:t>
+              <a:t>Scalability:</a:t>
+            </a:r>
+            <a:r>
+              <a:rPr lang="en-GB" sz="1200" b="0">
+                <a:solidFill>
+                  <a:srgbClr val="333333"/>
+                </a:solidFill>
+                <a:latin typeface="Manrope"/>
+              </a:rPr>
+              <a:t> Lambda auto-scales 0 to 1,000+ concurrent executions.</a:t>
             </a:r>
           </a:p>
           <a:p>
@@ -7483,13 +7519,22 @@
               <a:buNone/>
             </a:pPr>
             <a:r>
-              <a:rPr lang="en-GB" sz="1100" b="0">
-                <a:solidFill>
-                  <a:srgbClr val="1a6b2e"/>
+              <a:rPr lang="en-GB" sz="1200" b="1">
+                <a:solidFill>
+                  <a:srgbClr val="333333"/>
                 </a:solidFill>
                 <a:latin typeface="Manrope"/>
               </a:rPr>
-              <a:t>PWA Lighthouse: Performance 85 | Accessibility 92 | Best Practices 95 | SEO 90</a:t>
+              <a:t>PWA Lighthouse:</a:t>
+            </a:r>
+            <a:r>
+              <a:rPr lang="en-GB" sz="1200" b="0">
+                <a:solidFill>
+                  <a:srgbClr val="333333"/>
+                </a:solidFill>
+                <a:latin typeface="Manrope"/>
+              </a:rPr>
+              <a:t> Performance 85 | Accessibility 92 | Best Practices 95 | SEO 90</a:t>
             </a:r>
           </a:p>
         </p:txBody>
@@ -7636,13 +7681,22 @@
               <a:buNone/>
             </a:pPr>
             <a:r>
-              <a:rPr lang="en-GB" sz="1100" b="0">
-                <a:solidFill>
-                  <a:srgbClr val="1a6b2e"/>
+              <a:rPr lang="en-GB" sz="1200" b="1">
+                <a:solidFill>
+                  <a:srgbClr val="333333"/>
                 </a:solidFill>
                 <a:latin typeface="Manrope"/>
               </a:rPr>
-              <a:t>Phase 2 (Q2 2026): Multi-language — Tamil, Telugu, Marathi, Bengali via Amazon Translate + Polly. WhatsApp integration.</a:t>
+              <a:t>Phase 2 (Q2 2026):</a:t>
+            </a:r>
+            <a:r>
+              <a:rPr lang="en-GB" sz="1200" b="0">
+                <a:solidFill>
+                  <a:srgbClr val="333333"/>
+                </a:solidFill>
+                <a:latin typeface="Manrope"/>
+              </a:rPr>
+              <a:t> Multi-language — Tamil, Telugu, Marathi, Bengali via Amazon Translate + Polly. WhatsApp integration.</a:t>
             </a:r>
           </a:p>
           <a:p>
@@ -7659,13 +7713,22 @@
               <a:buNone/>
             </a:pPr>
             <a:r>
-              <a:rPr lang="en-GB" sz="1100" b="0">
-                <a:solidFill>
-                  <a:srgbClr val="1a6b2e"/>
+              <a:rPr lang="en-GB" sz="1200" b="1">
+                <a:solidFill>
+                  <a:srgbClr val="333333"/>
                 </a:solidFill>
                 <a:latin typeface="Manrope"/>
               </a:rPr>
-              <a:t>Phase 3 (Q3 2026): Crop disease detection from leaf photos (custom Rekognition model). Auto-generate PMFBY claims.</a:t>
+              <a:t>Phase 3 (Q3 2026):</a:t>
+            </a:r>
+            <a:r>
+              <a:rPr lang="en-GB" sz="1200" b="0">
+                <a:solidFill>
+                  <a:srgbClr val="333333"/>
+                </a:solidFill>
+                <a:latin typeface="Manrope"/>
+              </a:rPr>
+              <a:t> Crop disease detection from leaf photos (custom Rekognition model). Auto-generate PMFBY claims.</a:t>
             </a:r>
           </a:p>
           <a:p>
@@ -7682,13 +7745,22 @@
               <a:buNone/>
             </a:pPr>
             <a:r>
-              <a:rPr lang="en-GB" sz="1100" b="0">
-                <a:solidFill>
-                  <a:srgbClr val="1a6b2e"/>
+              <a:rPr lang="en-GB" sz="1200" b="1">
+                <a:solidFill>
+                  <a:srgbClr val="333333"/>
                 </a:solidFill>
                 <a:latin typeface="Manrope"/>
               </a:rPr>
-              <a:t>Phase 4 (Q4 2026): FPO dashboard for 100+ farmers. PM-KISAN + eNAM API integration. IoT weather alerts.</a:t>
+              <a:t>Phase 4 (Q4 2026):</a:t>
+            </a:r>
+            <a:r>
+              <a:rPr lang="en-GB" sz="1200" b="0">
+                <a:solidFill>
+                  <a:srgbClr val="333333"/>
+                </a:solidFill>
+                <a:latin typeface="Manrope"/>
+              </a:rPr>
+              <a:t> FPO dashboard for 100+ farmers. PM-KISAN + eNAM API integration. IoT weather alerts.</a:t>
             </a:r>
           </a:p>
           <a:p>
@@ -7705,13 +7777,22 @@
               <a:buNone/>
             </a:pPr>
             <a:r>
-              <a:rPr lang="en-GB" sz="1100" b="0">
-                <a:solidFill>
-                  <a:srgbClr val="1a6b2e"/>
+              <a:rPr lang="en-GB" sz="1200" b="1">
+                <a:solidFill>
+                  <a:srgbClr val="333333"/>
                 </a:solidFill>
                 <a:latin typeface="Manrope"/>
               </a:rPr>
-              <a:t>Business: B2G (State Agri Depts) | B2B (agri-input companies) | Freemium (premium crop analytics).</a:t>
+              <a:t>Business:</a:t>
+            </a:r>
+            <a:r>
+              <a:rPr lang="en-GB" sz="1200" b="0">
+                <a:solidFill>
+                  <a:srgbClr val="333333"/>
+                </a:solidFill>
+                <a:latin typeface="Manrope"/>
+              </a:rPr>
+              <a:t> B2G (State Agri Depts) | B2B (agri-input companies) | Freemium (premium crop analytics).</a:t>
             </a:r>
           </a:p>
           <a:p>
@@ -7728,13 +7809,22 @@
               <a:buNone/>
             </a:pPr>
             <a:r>
-              <a:rPr lang="en-GB" sz="1100" b="0">
-                <a:solidFill>
-                  <a:srgbClr val="1a6b2e"/>
+              <a:rPr lang="en-GB" sz="1200" b="1">
+                <a:solidFill>
+                  <a:srgbClr val="333333"/>
                 </a:solidFill>
                 <a:latin typeface="Manrope"/>
               </a:rPr>
-              <a:t>Target: 1 million farmers by 2027. 30% reduction in preventable farm accidents.</a:t>
+              <a:t>Target:</a:t>
+            </a:r>
+            <a:r>
+              <a:rPr lang="en-GB" sz="1200" b="0">
+                <a:solidFill>
+                  <a:srgbClr val="333333"/>
+                </a:solidFill>
+                <a:latin typeface="Manrope"/>
+              </a:rPr>
+              <a:t> 1 million farmers by 2027. 30% reduction in preventable farm accidents.</a:t>
             </a:r>
           </a:p>
         </p:txBody>
@@ -7935,9 +8025,9 @@
               <a:buNone/>
             </a:pPr>
             <a:r>
-              <a:rPr lang="en-GB" sz="1100" b="0">
-                <a:solidFill>
-                  <a:srgbClr val="1a6b2e"/>
+              <a:rPr lang="en-GB" sz="1200" b="0">
+                <a:solidFill>
+                  <a:srgbClr val="333333"/>
                 </a:solidFill>
                 <a:latin typeface="Manrope"/>
               </a:rPr>
@@ -7998,9 +8088,9 @@
               <a:buNone/>
             </a:pPr>
             <a:r>
-              <a:rPr lang="en-GB" sz="1100" b="0">
-                <a:solidFill>
-                  <a:srgbClr val="1a6b2e"/>
+              <a:rPr lang="en-GB" sz="1200" b="0">
+                <a:solidFill>
+                  <a:srgbClr val="333333"/>
                 </a:solidFill>
                 <a:latin typeface="Manrope"/>
               </a:rPr>
@@ -8187,9 +8277,9 @@
               <a:buNone/>
             </a:pPr>
             <a:r>
-              <a:rPr lang="en-GB" sz="1100" b="0">
-                <a:solidFill>
-                  <a:srgbClr val="1a6b2e"/>
+              <a:rPr lang="en-GB" sz="1200" b="0">
+                <a:solidFill>
+                  <a:srgbClr val="333333"/>
                 </a:solidFill>
                 <a:latin typeface="Manrope"/>
               </a:rPr>
@@ -8210,9 +8300,9 @@
               <a:buNone/>
             </a:pPr>
             <a:r>
-              <a:rPr lang="en-GB" sz="1100" b="0">
-                <a:solidFill>
-                  <a:srgbClr val="1a6b2e"/>
+              <a:rPr lang="en-GB" sz="1200" b="0">
+                <a:solidFill>
+                  <a:srgbClr val="333333"/>
                 </a:solidFill>
                 <a:latin typeface="Manrope"/>
               </a:rPr>
@@ -8387,9 +8477,9 @@
               <a:buNone/>
             </a:pPr>
             <a:r>
-              <a:rPr lang="en-GB" sz="1100" b="0">
-                <a:solidFill>
-                  <a:srgbClr val="1a6b2e"/>
+              <a:rPr lang="en-GB" sz="1200" b="0">
+                <a:solidFill>
+                  <a:srgbClr val="333333"/>
                 </a:solidFill>
                 <a:latin typeface="Manrope"/>
               </a:rPr>
@@ -8450,9 +8540,9 @@
               <a:buNone/>
             </a:pPr>
             <a:r>
-              <a:rPr lang="en-GB" sz="1100" b="0">
-                <a:solidFill>
-                  <a:srgbClr val="1a6b2e"/>
+              <a:rPr lang="en-GB" sz="1200" b="0">
+                <a:solidFill>
+                  <a:srgbClr val="333333"/>
                 </a:solidFill>
                 <a:latin typeface="Manrope"/>
               </a:rPr>
@@ -8513,9 +8603,9 @@
               <a:buNone/>
             </a:pPr>
             <a:r>
-              <a:rPr lang="en-GB" sz="1100" b="0">
-                <a:solidFill>
-                  <a:srgbClr val="1a6b2e"/>
+              <a:rPr lang="en-GB" sz="1200" b="0">
+                <a:solidFill>
+                  <a:srgbClr val="333333"/>
                 </a:solidFill>
                 <a:latin typeface="Manrope"/>
               </a:rPr>
@@ -8677,13 +8767,22 @@
               <a:buNone/>
             </a:pPr>
             <a:r>
-              <a:rPr lang="en-GB" sz="1100" b="0">
-                <a:solidFill>
-                  <a:srgbClr val="1a6b2e"/>
+              <a:rPr lang="en-GB" sz="1200" b="1">
+                <a:solidFill>
+                  <a:srgbClr val="333333"/>
                 </a:solidFill>
                 <a:latin typeface="Manrope"/>
               </a:rPr>
-              <a:t>1. Voice Q&amp;A — Ask safety questions in Hindi/English. Bedrock RAG answers, Amazon Polly speaks the response. Zero reading required.</a:t>
+              <a:t>1. Voice Q&amp;A</a:t>
+            </a:r>
+            <a:r>
+              <a:rPr lang="en-GB" sz="1200" b="0">
+                <a:solidFill>
+                  <a:srgbClr val="333333"/>
+                </a:solidFill>
+                <a:latin typeface="Manrope"/>
+              </a:rPr>
+              <a:t> — Ask safety questions in Hindi/English. Bedrock RAG answers, Amazon Polly speaks the response. Zero reading required.</a:t>
             </a:r>
           </a:p>
           <a:p>
@@ -8700,13 +8799,22 @@
               <a:buNone/>
             </a:pPr>
             <a:r>
-              <a:rPr lang="en-GB" sz="1100" b="0">
-                <a:solidFill>
-                  <a:srgbClr val="1a6b2e"/>
+              <a:rPr lang="en-GB" sz="1200" b="1">
+                <a:solidFill>
+                  <a:srgbClr val="333333"/>
                 </a:solidFill>
                 <a:latin typeface="Manrope"/>
               </a:rPr>
-              <a:t>2. AI Hazard Detection — Point camera at field or equipment. Rekognition identifies pesticide containers, unsafe postures, missing PPE instantly.</a:t>
+              <a:t>2. AI Hazard Detection</a:t>
+            </a:r>
+            <a:r>
+              <a:rPr lang="en-GB" sz="1200" b="0">
+                <a:solidFill>
+                  <a:srgbClr val="333333"/>
+                </a:solidFill>
+                <a:latin typeface="Manrope"/>
+              </a:rPr>
+              <a:t> — Point camera at field or equipment. Rekognition identifies pesticide containers, unsafe postures, missing PPE instantly.</a:t>
             </a:r>
           </a:p>
           <a:p>
@@ -8723,13 +8831,22 @@
               <a:buNone/>
             </a:pPr>
             <a:r>
-              <a:rPr lang="en-GB" sz="1100" b="0">
-                <a:solidFill>
-                  <a:srgbClr val="1a6b2e"/>
+              <a:rPr lang="en-GB" sz="1200" b="1">
+                <a:solidFill>
+                  <a:srgbClr val="333333"/>
                 </a:solidFill>
                 <a:latin typeface="Manrope"/>
               </a:rPr>
-              <a:t>3. JHA Safety Checklists — 8 pre-built templates: Pesticide Spraying, Tractor Operation, Harvesting, Irrigation, Fertilizer, Night Work, Heavy Equipment, Chemical Storage.</a:t>
+              <a:t>3. JHA Safety Checklists</a:t>
+            </a:r>
+            <a:r>
+              <a:rPr lang="en-GB" sz="1200" b="0">
+                <a:solidFill>
+                  <a:srgbClr val="333333"/>
+                </a:solidFill>
+                <a:latin typeface="Manrope"/>
+              </a:rPr>
+              <a:t> — 8 pre-built templates: Pesticide Spraying, Tractor Operation, Harvesting, Irrigation, Fertilizer, Night Work, Heavy Equipment, Chemical Storage.</a:t>
             </a:r>
           </a:p>
           <a:p>
@@ -8746,13 +8863,22 @@
               <a:buNone/>
             </a:pPr>
             <a:r>
-              <a:rPr lang="en-GB" sz="1100" b="0">
-                <a:solidFill>
-                  <a:srgbClr val="1a6b2e"/>
+              <a:rPr lang="en-GB" sz="1200" b="1">
+                <a:solidFill>
+                  <a:srgbClr val="333333"/>
                 </a:solidFill>
                 <a:latin typeface="Manrope"/>
               </a:rPr>
-              <a:t>4. User Profile — Farmer sets name, location, crop type. App delivers personalised daily safety tips and seasonal hazard warnings.</a:t>
+              <a:t>4. User Profile</a:t>
+            </a:r>
+            <a:r>
+              <a:rPr lang="en-GB" sz="1200" b="0">
+                <a:solidFill>
+                  <a:srgbClr val="333333"/>
+                </a:solidFill>
+                <a:latin typeface="Manrope"/>
+              </a:rPr>
+              <a:t> — Farmer sets name, location, crop type. App delivers personalised daily safety tips and seasonal hazard warnings.</a:t>
             </a:r>
           </a:p>
           <a:p>
@@ -8769,13 +8895,22 @@
               <a:buNone/>
             </a:pPr>
             <a:r>
-              <a:rPr lang="en-GB" sz="1100" b="0">
-                <a:solidFill>
-                  <a:srgbClr val="1a6b2e"/>
+              <a:rPr lang="en-GB" sz="1200" b="1">
+                <a:solidFill>
+                  <a:srgbClr val="333333"/>
                 </a:solidFill>
                 <a:latin typeface="Manrope"/>
               </a:rPr>
-              <a:t>5. Government Schemes Directory — 8 national schemes (PM-KISAN, PMFBY, KCC, Soil Health Card, eNAM etc.) with search and direct apply links.</a:t>
+              <a:t>5. Government Schemes Directory</a:t>
+            </a:r>
+            <a:r>
+              <a:rPr lang="en-GB" sz="1200" b="0">
+                <a:solidFill>
+                  <a:srgbClr val="333333"/>
+                </a:solidFill>
+                <a:latin typeface="Manrope"/>
+              </a:rPr>
+              <a:t> — 8 national schemes (PM-KISAN, PMFBY, KCC, Soil Health Card, eNAM etc.) with search and direct apply links.</a:t>
             </a:r>
           </a:p>
           <a:p>
@@ -8792,13 +8927,22 @@
               <a:buNone/>
             </a:pPr>
             <a:r>
-              <a:rPr lang="en-GB" sz="1100" b="0">
-                <a:solidFill>
-                  <a:srgbClr val="1a6b2e"/>
+              <a:rPr lang="en-GB" sz="1200" b="1">
+                <a:solidFill>
+                  <a:srgbClr val="333333"/>
                 </a:solidFill>
                 <a:latin typeface="Manrope"/>
               </a:rPr>
-              <a:t>6. Offline-First PWA — Installable on any phone, works without internet. Built for low-connectivity rural India.</a:t>
+              <a:t>6. Offline-First PWA</a:t>
+            </a:r>
+            <a:r>
+              <a:rPr lang="en-GB" sz="1200" b="0">
+                <a:solidFill>
+                  <a:srgbClr val="333333"/>
+                </a:solidFill>
+                <a:latin typeface="Manrope"/>
+              </a:rPr>
+              <a:t> — Installable on any phone, works without internet. Built for low-connectivity rural India.</a:t>
             </a:r>
           </a:p>
           <a:p>
@@ -8851,9 +8995,9 @@
               <a:buNone/>
             </a:pPr>
             <a:r>
-              <a:rPr lang="en-GB" sz="1100" b="0">
-                <a:solidFill>
-                  <a:srgbClr val="1a6b2e"/>
+              <a:rPr lang="en-GB" sz="1200" b="0">
+                <a:solidFill>
+                  <a:srgbClr val="333333"/>
                 </a:solidFill>
                 <a:latin typeface="Manrope"/>
               </a:rPr>
@@ -9438,13 +9582,22 @@
               <a:buNone/>
             </a:pPr>
             <a:r>
-              <a:rPr lang="en-GB" sz="1100" b="0">
-                <a:solidFill>
-                  <a:srgbClr val="1a6b2e"/>
+              <a:rPr lang="en-GB" sz="1200" b="1">
+                <a:solidFill>
+                  <a:srgbClr val="333333"/>
                 </a:solidFill>
                 <a:latin typeface="Manrope"/>
               </a:rPr>
-              <a:t>Frontend: React 18 + Vite, Tailwind CSS v4, React Router v6, Progressive Web App (offline-first), Web Speech API for voice input, JavaScript ES2022.</a:t>
+              <a:t>Frontend:</a:t>
+            </a:r>
+            <a:r>
+              <a:rPr lang="en-GB" sz="1200" b="0">
+                <a:solidFill>
+                  <a:srgbClr val="333333"/>
+                </a:solidFill>
+                <a:latin typeface="Manrope"/>
+              </a:rPr>
+              <a:t> React 18 + Vite, Tailwind CSS v4, React Router v6, Progressive Web App (offline-first), Web Speech API for voice input, JavaScript ES2022.</a:t>
             </a:r>
           </a:p>
           <a:p>
@@ -9461,13 +9614,22 @@
               <a:buNone/>
             </a:pPr>
             <a:r>
-              <a:rPr lang="en-GB" sz="1100" b="0">
-                <a:solidFill>
-                  <a:srgbClr val="1a6b2e"/>
+              <a:rPr lang="en-GB" sz="1200" b="1">
+                <a:solidFill>
+                  <a:srgbClr val="333333"/>
                 </a:solidFill>
                 <a:latin typeface="Manrope"/>
               </a:rPr>
-              <a:t>AWS Services (10 total): Amazon Bedrock (GenAI/RAG) | Rekognition (Computer Vision) | Polly (Hindi TTS) | API Gateway | Lambda (Node.js 18, ARM64) | DynamoDB | S3 | CloudFront | IAM | CloudWatch.</a:t>
+              <a:t>AWS Services (10 total):</a:t>
+            </a:r>
+            <a:r>
+              <a:rPr lang="en-GB" sz="1200" b="0">
+                <a:solidFill>
+                  <a:srgbClr val="333333"/>
+                </a:solidFill>
+                <a:latin typeface="Manrope"/>
+              </a:rPr>
+              <a:t> Amazon Bedrock (GenAI/RAG) | Rekognition (Computer Vision) | Polly (Hindi TTS) | API Gateway | Lambda (Node.js 18, ARM64) | DynamoDB | S3 | CloudFront | IAM | CloudWatch.</a:t>
             </a:r>
           </a:p>
           <a:p>
@@ -9484,13 +9646,22 @@
               <a:buNone/>
             </a:pPr>
             <a:r>
-              <a:rPr lang="en-GB" sz="1100" b="0">
-                <a:solidFill>
-                  <a:srgbClr val="1a6b2e"/>
+              <a:rPr lang="en-GB" sz="1200" b="1">
+                <a:solidFill>
+                  <a:srgbClr val="333333"/>
                 </a:solidFill>
                 <a:latin typeface="Manrope"/>
               </a:rPr>
-              <a:t>Deployment: AWS CLI, S3 sync + CloudFront invalidation via shell scripts. Region: ap-south-1. Fully serverless — zero EC2, auto-scales 0 to 1,000+ concurrent users.</a:t>
+              <a:t>Deployment:</a:t>
+            </a:r>
+            <a:r>
+              <a:rPr lang="en-GB" sz="1200" b="0">
+                <a:solidFill>
+                  <a:srgbClr val="333333"/>
+                </a:solidFill>
+                <a:latin typeface="Manrope"/>
+              </a:rPr>
+              <a:t> AWS CLI, S3 sync + CloudFront invalidation via shell scripts. Region: ap-south-1. Fully serverless — zero EC2, auto-scales 0 to 1,000+ concurrent users.</a:t>
             </a:r>
           </a:p>
         </p:txBody>
@@ -9621,9 +9792,9 @@
               <a:buNone/>
             </a:pPr>
             <a:r>
-              <a:rPr lang="en-GB" sz="1100" b="0">
-                <a:solidFill>
-                  <a:srgbClr val="1a6b2e"/>
+              <a:rPr lang="en-GB" sz="1200" b="0">
+                <a:solidFill>
+                  <a:srgbClr val="333333"/>
                 </a:solidFill>
                 <a:latin typeface="Manrope"/>
               </a:rPr>
@@ -9644,13 +9815,22 @@
               <a:buNone/>
             </a:pPr>
             <a:r>
-              <a:rPr lang="en-GB" sz="1100" b="0">
-                <a:solidFill>
-                  <a:srgbClr val="1a6b2e"/>
+              <a:rPr lang="en-GB" sz="1200" b="1">
+                <a:solidFill>
+                  <a:srgbClr val="333333"/>
                 </a:solidFill>
                 <a:latin typeface="Manrope"/>
               </a:rPr>
-              <a:t>Bedrock (Claude 3 Haiku RAG): ~$2-5/month  |  Rekognition: ~$1/month  |  Polly TTS: ~$0.40/month</a:t>
+              <a:t>Bedrock (Claude 3 Haiku RAG):</a:t>
+            </a:r>
+            <a:r>
+              <a:rPr lang="en-GB" sz="1200" b="0">
+                <a:solidFill>
+                  <a:srgbClr val="333333"/>
+                </a:solidFill>
+                <a:latin typeface="Manrope"/>
+              </a:rPr>
+              <a:t> ~$2-5/month  |  Rekognition: ~$1/month  |  Polly TTS: ~$0.40/month</a:t>
             </a:r>
           </a:p>
           <a:p>
@@ -9667,13 +9847,22 @@
               <a:buNone/>
             </a:pPr>
             <a:r>
-              <a:rPr lang="en-GB" sz="1100" b="0">
-                <a:solidFill>
-                  <a:srgbClr val="1a6b2e"/>
+              <a:rPr lang="en-GB" sz="1200" b="1">
+                <a:solidFill>
+                  <a:srgbClr val="333333"/>
                 </a:solidFill>
                 <a:latin typeface="Manrope"/>
               </a:rPr>
-              <a:t>Lambda + API Gateway + DynamoDB + S3 + CloudFront + IAM + CloudWatch: FREE (within AWS free tier)</a:t>
+              <a:t>Lambda + API Gateway + DynamoDB + S3 + CloudFront + IAM + CloudWatch:</a:t>
+            </a:r>
+            <a:r>
+              <a:rPr lang="en-GB" sz="1200" b="0">
+                <a:solidFill>
+                  <a:srgbClr val="333333"/>
+                </a:solidFill>
+                <a:latin typeface="Manrope"/>
+              </a:rPr>
+              <a:t> FREE (within AWS free tier)</a:t>
             </a:r>
           </a:p>
           <a:p>
@@ -9690,13 +9879,22 @@
               <a:buNone/>
             </a:pPr>
             <a:r>
-              <a:rPr lang="en-GB" sz="1100" b="0">
-                <a:solidFill>
-                  <a:srgbClr val="1a6b2e"/>
+              <a:rPr lang="en-GB" sz="1200" b="1">
+                <a:solidFill>
+                  <a:srgbClr val="333333"/>
                 </a:solidFill>
                 <a:latin typeface="Manrope"/>
               </a:rPr>
-              <a:t>Total: ~$4-7/month for 1,000 farmers = less than Rs.0.60 per farmer per month.</a:t>
+              <a:t>Total:</a:t>
+            </a:r>
+            <a:r>
+              <a:rPr lang="en-GB" sz="1200" b="0">
+                <a:solidFill>
+                  <a:srgbClr val="333333"/>
+                </a:solidFill>
+                <a:latin typeface="Manrope"/>
+              </a:rPr>
+              <a:t> ~$4-7/month for 1,000 farmers = less than Rs.0.60 per farmer per month.</a:t>
             </a:r>
           </a:p>
           <a:p>
@@ -9713,13 +9911,22 @@
               <a:buNone/>
             </a:pPr>
             <a:r>
-              <a:rPr lang="en-GB" sz="1100" b="0">
-                <a:solidFill>
-                  <a:srgbClr val="1a6b2e"/>
+              <a:rPr lang="en-GB" sz="1200" b="1">
+                <a:solidFill>
+                  <a:srgbClr val="333333"/>
                 </a:solidFill>
                 <a:latin typeface="Manrope"/>
               </a:rPr>
-              <a:t>At 10,000 farmers: ~$40-70/month. True pay-per-use — $0 when idle.</a:t>
+              <a:t>At 10,000 farmers:</a:t>
+            </a:r>
+            <a:r>
+              <a:rPr lang="en-GB" sz="1200" b="0">
+                <a:solidFill>
+                  <a:srgbClr val="333333"/>
+                </a:solidFill>
+                <a:latin typeface="Manrope"/>
+              </a:rPr>
+              <a:t> ~$40-70/month. True pay-per-use — $0 when idle.</a:t>
             </a:r>
           </a:p>
         </p:txBody>

</xml_diff>